<commit_message>
docs: CORES bearer token rotated 2026-06-29 (hscdownloader) + shared PreciousMetalReader auth.py now 403
</commit_message>
<xml_diff>
--- a/presentation/NanofabToolkit/PreciousMetalReader/slides/PreciousMetalReader.pptx
+++ b/presentation/NanofabToolkit/PreciousMetalReader/slides/PreciousMetalReader.pptx
@@ -599,7 +599,7 @@
           <a:p>
             <a:r>
               <a:rPr lang="en-US" dirty="0"/>
-              <a:t>Wrap up. PreciousMetalReader is a one-button monthly billing helper that talks to CORES directly. Don't confuse it with HSCDownloader (same source, different data, different purpose). The headline maintenance item is the embedded token. Questions welcome.</a:t>
+              <a:t>Wrap up. PreciousMetalReader is a one-button monthly billing helper that talks to CORES directly. Don't confuse it with HSCDownloader (same source, different data, different purpose). The headline maintenance item is applying the rotated CORES token (set CORES_TOKEN and rebuild) so downloads work again. Questions welcome.</a:t>
             </a:r>
             <a:endParaRPr lang="en-US" dirty="0"/>
           </a:p>
@@ -1127,7 +1127,7 @@
           <a:p>
             <a:r>
               <a:rPr lang="en-US" dirty="0"/>
-              <a:t>Be candid about the security caveat. CORES needs a bearer token to authorize the request. Right now the token is in a Python file shipped with the app, which is a credential leak risk — anyone with a copy of the app has the token. The recommendation in the developer notes is to move it out into a protected setting and rotate it. Same recommendation applies to HSCDownloader.</a:t>
+              <a:t>Be candid about the security caveat. CORES needs a bearer token to authorize the request. The app now prefers a protected setting (the CORES_TOKEN environment variable) over the old token baked into a Python file. The shared CORES token was rotated on 2026-06-29, so the old built-in value no longer works (it returns 403) — each machine needs the new token set and the app rebuilt. The sibling HSCDownloader, which shares this token, has already been updated.</a:t>
             </a:r>
             <a:endParaRPr lang="en-US" dirty="0"/>
           </a:p>
@@ -2200,7 +2200,7 @@
                 <a:ea typeface="Calibri" pitchFamily="34" charset="-122"/>
                 <a:cs typeface="Calibri" pitchFamily="34" charset="-120"/>
               </a:rPr>
-              <a:t>Cousin of HSCDownloader; same source, different data.</a:t>
+              <a:t>Cousin of HSCDownloader; same source, same token, different data.</a:t>
             </a:r>
             <a:endParaRPr lang="en-US" sz="1500" dirty="0"/>
           </a:p>
@@ -2221,7 +2221,7 @@
                 <a:ea typeface="Calibri" pitchFamily="34" charset="-122"/>
                 <a:cs typeface="Calibri" pitchFamily="34" charset="-120"/>
               </a:rPr>
-              <a:t>Watch the embedded access token — move it out for safety.</a:t>
+              <a:t>The shared CORES token was rotated 2026-06-29 — apply the new token and rebuild.</a:t>
             </a:r>
             <a:endParaRPr lang="en-US" sz="1500" dirty="0"/>
           </a:p>
@@ -4692,7 +4692,7 @@
                 <a:ea typeface="Calibri" pitchFamily="34" charset="-122"/>
                 <a:cs typeface="Calibri" pitchFamily="34" charset="-120"/>
               </a:rPr>
-              <a:t>The token is currently written into the app itself.</a:t>
+              <a:t>The app now reads the token from a setting (CORES_TOKEN), not baked in.</a:t>
             </a:r>
             <a:endParaRPr lang="en-US" sz="1500" dirty="0"/>
           </a:p>
@@ -4713,7 +4713,7 @@
                 <a:ea typeface="Calibri" pitchFamily="34" charset="-122"/>
                 <a:cs typeface="Calibri" pitchFamily="34" charset="-120"/>
               </a:rPr>
-              <a:t>Standard expectation: move it into a protected setting and rotate it.</a:t>
+              <a:t>The shared CORES token was rotated 2026-06-29 — the old built-in value no longer works (403).</a:t>
             </a:r>
             <a:endParaRPr lang="en-US" sz="1500" dirty="0"/>
           </a:p>
@@ -4734,7 +4734,7 @@
                 <a:ea typeface="Calibri" pitchFamily="34" charset="-122"/>
                 <a:cs typeface="Calibri" pitchFamily="34" charset="-120"/>
               </a:rPr>
-              <a:t>On the to-fix list — it's a real credential.</a:t>
+              <a:t>To-do: apply the new token on each machine and rebuild the app.</a:t>
             </a:r>
             <a:endParaRPr lang="en-US" sz="1500" dirty="0"/>
           </a:p>

</xml_diff>